<commit_message>
DRV: Presentation - 2
</commit_message>
<xml_diff>
--- a/DRV/vmodem_driver_presentation_clean.pptx
+++ b/DRV/vmodem_driver_presentation_clean.pptx
@@ -7839,7 +7839,62 @@
                 <a:ea typeface="Arial" pitchFamily="34" charset="-122"/>
                 <a:cs typeface="Arial" pitchFamily="34" charset="-120"/>
               </a:rPr>
-              <a:t>Модуль ядра создаёт от 1 до 16 устройств /dev/vmodemN.</a:t>
+              <a:t>Модуль ядра создаёт от 1 до 16 устройств /dev/</a:t>
+            </a:r>
+            <a:r>
+              <a:rPr lang="ru-RU" altLang="en-US" sz="1700" dirty="0" err="1">
+                <a:solidFill>
+                  <a:srgbClr val="CBD5E1"/>
+                </a:solidFill>
+                <a:latin typeface="Arial" pitchFamily="34" charset="0"/>
+                <a:ea typeface="Arial" pitchFamily="34" charset="-122"/>
+                <a:cs typeface="Arial" pitchFamily="34" charset="-120"/>
+              </a:rPr>
+              <a:t>vmodemN</a:t>
+            </a:r>
+            <a:r>
+              <a:rPr lang="en-US" altLang="en-US" sz="1700" dirty="0">
+                <a:solidFill>
+                  <a:srgbClr val="CBD5E1"/>
+                </a:solidFill>
+                <a:latin typeface="Arial" pitchFamily="34" charset="0"/>
+                <a:ea typeface="Arial" pitchFamily="34" charset="-122"/>
+                <a:cs typeface="Arial" pitchFamily="34" charset="-120"/>
+              </a:rPr>
+              <a:t>, </a:t>
+            </a:r>
+            <a:r>
+              <a:rPr lang="ru-RU" altLang="en-US" sz="1700" dirty="0">
+                <a:solidFill>
+                  <a:srgbClr val="CBD5E1"/>
+                </a:solidFill>
+                <a:latin typeface="Arial" pitchFamily="34" charset="0"/>
+                <a:ea typeface="Arial" pitchFamily="34" charset="-122"/>
+                <a:cs typeface="Arial" pitchFamily="34" charset="-120"/>
+              </a:rPr>
+              <a:t>имитирующих работу </a:t>
+            </a:r>
+            <a:r>
+              <a:rPr lang="en-US" altLang="en-US" sz="1700" dirty="0">
+                <a:solidFill>
+                  <a:srgbClr val="CBD5E1"/>
+                </a:solidFill>
+                <a:latin typeface="Arial" pitchFamily="34" charset="0"/>
+                <a:ea typeface="Arial" pitchFamily="34" charset="-122"/>
+                <a:cs typeface="Arial" pitchFamily="34" charset="-120"/>
+              </a:rPr>
+              <a:t>GSM / LTE </a:t>
+            </a:r>
+            <a:r>
+              <a:rPr lang="ru-RU" altLang="en-US" sz="1700" dirty="0">
+                <a:solidFill>
+                  <a:srgbClr val="CBD5E1"/>
+                </a:solidFill>
+                <a:latin typeface="Arial" pitchFamily="34" charset="0"/>
+                <a:ea typeface="Arial" pitchFamily="34" charset="-122"/>
+                <a:cs typeface="Arial" pitchFamily="34" charset="-120"/>
+              </a:rPr>
+              <a:t>модемов.</a:t>
             </a:r>
             <a:endParaRPr lang="ru-RU" sz="1700" dirty="0"/>
           </a:p>

</xml_diff>